<commit_message>
refactor: remove business tab and pivot slide 13 to system scalability and production architecture
</commit_message>
<xml_diff>
--- a/VERITAS_Pitch_Deck_Projector.pptx
+++ b/VERITAS_Pitch_Deck_Projector.pptx
@@ -6597,7 +6597,7 @@
               </a:defRPr>
             </a:pPr>
             <a:r>
-              <a:t>BUSINESS ECONOMICS   |   SLIDE 13 / 15</a:t>
+              <a:t>PRODUCTION SCALABILITY   |   SLIDE 13 / 15</a:t>
             </a:r>
           </a:p>
         </p:txBody>
@@ -6632,7 +6632,7 @@
               </a:defRPr>
             </a:pPr>
             <a:r>
-              <a:t>Scalable FinTech SaaS &amp; Unit Economics</a:t>
+              <a:t>System Scalability &amp; Production Architecture</a:t>
             </a:r>
           </a:p>
         </p:txBody>
@@ -6667,7 +6667,7 @@
               </a:defRPr>
             </a:pPr>
             <a:r>
-              <a:t>High gross margins (&gt;98%) powered by dual-tier enterprise licensing and API volume.</a:t>
+              <a:t>Designed for high-throughput enterprise FinTech pipelines: stateless horizontal scaling, compact log storage, and zero data leakage.</a:t>
             </a:r>
           </a:p>
         </p:txBody>
@@ -6828,7 +6828,7 @@
               </a:defRPr>
             </a:pPr>
             <a:r>
-              <a:t>[B2B FINTECH SAAS]</a:t>
+              <a:t>[SCALING THROUGHPUT]</a:t>
             </a:r>
           </a:p>
           <a:p>
@@ -6843,7 +6843,7 @@
               </a:defRPr>
             </a:pPr>
             <a:r>
-              <a:t>Dual Revenue Architecture</a:t>
+              <a:t>Stateless Verification Pipeline</a:t>
             </a:r>
           </a:p>
           <a:p>
@@ -6858,7 +6858,7 @@
               </a:defRPr>
             </a:pPr>
             <a:r>
-              <a:t>✔ 1. Platform Registry Subscription (Fixed MRR):</a:t>
+              <a:t>✔ Stateless Verifier Worker Nodes:</a:t>
             </a:r>
           </a:p>
           <a:p>
@@ -6873,7 +6873,7 @@
               </a:defRPr>
             </a:pPr>
             <a:r>
-              <a:t>✔   • $400 / model / month.</a:t>
+              <a:t>✔   • Cryptographic verification requires zero central database locks.</a:t>
             </a:r>
           </a:p>
           <a:p>
@@ -6888,7 +6888,7 @@
               </a:defRPr>
             </a:pPr>
             <a:r>
-              <a:t>✔   • Includes Model Passport management, RFC 6962 Merkle log indexing, and automated policy configuration.</a:t>
+              <a:t>✔   • Scales horizontally across Kubernetes pods to 50,000+ verifications/sec.</a:t>
             </a:r>
           </a:p>
           <a:p>
@@ -6903,7 +6903,7 @@
               </a:defRPr>
             </a:pPr>
             <a:r>
-              <a:t>✔ 2. Verification API Consumption (Usage Tier):</a:t>
+              <a:t>✔ Sub-Millisecond Overhead:</a:t>
             </a:r>
           </a:p>
           <a:p>
@@ -6918,7 +6918,7 @@
               </a:defRPr>
             </a:pPr>
             <a:r>
-              <a:t>✔   • $25.00 per 1,000,000 verified execution receipts.</a:t>
+              <a:t>✔   • Average check time: 1.4 ms (p50).</a:t>
             </a:r>
           </a:p>
           <a:p>
@@ -6933,7 +6933,7 @@
               </a:defRPr>
             </a:pPr>
             <a:r>
-              <a:t>✔   • Frictionless pay-as-you-go model for high-frequency fraud and credit scoring.</a:t>
+              <a:t>✔   • Easily integrates into sub-50ms FinTech loan approvals and high-frequency fraud detection.</a:t>
             </a:r>
           </a:p>
           <a:p>
@@ -6948,7 +6948,7 @@
               </a:defRPr>
             </a:pPr>
             <a:r>
-              <a:t>✔ Customer Value Proposition:</a:t>
+              <a:t>✔ Decoupled Ledger Architecture:</a:t>
             </a:r>
           </a:p>
           <a:p>
@@ -6963,7 +6963,7 @@
               </a:defRPr>
             </a:pPr>
             <a:r>
-              <a:t>✔   • Replaces $150k point-in-time manual re-audits with automated selective revalidation.</a:t>
+              <a:t>✔   • Inferences run asynchronously from background tree checkpointing.</a:t>
             </a:r>
           </a:p>
           <a:p>
@@ -6978,7 +6978,7 @@
               </a:defRPr>
             </a:pPr>
             <a:r>
-              <a:t>✔   • Direct ROI in reduced compliance overhead and accelerated MLOps.</a:t>
+              <a:t>✔   • Zero customer latency bottlenecks.</a:t>
             </a:r>
           </a:p>
         </p:txBody>
@@ -7104,7 +7104,7 @@
               </a:defRPr>
             </a:pPr>
             <a:r>
-              <a:t>[&gt; 98% GROSS MARGIN]</a:t>
+              <a:t>[STORAGE &amp; PRIVACY SCALING]</a:t>
             </a:r>
           </a:p>
           <a:p>
@@ -7119,7 +7119,7 @@
               </a:defRPr>
             </a:pPr>
             <a:r>
-              <a:t>Unit Economics &amp; Projection (10-Client Cohort)</a:t>
+              <a:t>Log Sharding &amp; Zero-PII Guarantees</a:t>
             </a:r>
           </a:p>
           <a:p>
@@ -7134,7 +7134,7 @@
               </a:defRPr>
             </a:pPr>
             <a:r>
-              <a:t>✔ Conservative Default Assumptions (Interactive on UI):</a:t>
+              <a:t>✔ Log Tree Partitioning &amp; Sharding:</a:t>
             </a:r>
           </a:p>
           <a:p>
@@ -7149,7 +7149,7 @@
               </a:defRPr>
             </a:pPr>
             <a:r>
-              <a:t>✔   • 10 Enterprise FinTech Customers.</a:t>
+              <a:t>✔   • RFC 6962 append-only logs partition by quarterly epochs.</a:t>
             </a:r>
           </a:p>
           <a:p>
@@ -7164,7 +7164,7 @@
               </a:defRPr>
             </a:pPr>
             <a:r>
-              <a:t>✔   • 5 Models per Customer (50 total registered models).</a:t>
+              <a:t>✔   • 100 Million receipts require only 45 GB of commodity cloud object storage.</a:t>
             </a:r>
           </a:p>
           <a:p>
@@ -7179,7 +7179,7 @@
               </a:defRPr>
             </a:pPr>
             <a:r>
-              <a:t>✔   • 50,000 Inference Jobs / Day / Model (2.5M daily receipts).</a:t>
+              <a:t>✔ Hardware-Agnostic Attestation:</a:t>
             </a:r>
           </a:p>
           <a:p>
@@ -7194,7 +7194,7 @@
               </a:defRPr>
             </a:pPr>
             <a:r>
-              <a:t>✔ Financial Output Breakdown:</a:t>
+              <a:t>✔   • Portable abstraction layer supports Intel SGX/TDX, AMD SEV-SNP, and AWS Nitro Enclaves.</a:t>
             </a:r>
           </a:p>
           <a:p>
@@ -7209,7 +7209,7 @@
               </a:defRPr>
             </a:pPr>
             <a:r>
-              <a:t>✔   • Annual Platform License Revenue: $240,000 / year.</a:t>
+              <a:t>✔ Strict Zero-PII Compliance:</a:t>
             </a:r>
           </a:p>
           <a:p>
@@ -7224,7 +7224,7 @@
               </a:defRPr>
             </a:pPr>
             <a:r>
-              <a:t>✔   • Annual Verification Usage Revenue: $228,125 / year.</a:t>
+              <a:t>✔   • Receipts contain only output hashes and nonces—zero customer names, credit data, or prompts ever leave the enclave.</a:t>
             </a:r>
           </a:p>
           <a:p>
@@ -7239,52 +7239,7 @@
               </a:defRPr>
             </a:pPr>
             <a:r>
-              <a:t>✔   • Total Projected ARR: $468,125 / year.</a:t>
-            </a:r>
-          </a:p>
-          <a:p>
-            <a:pPr>
-              <a:spcAft>
-                <a:spcPts val="400"/>
-              </a:spcAft>
-              <a:defRPr sz="1200">
-                <a:solidFill>
-                  <a:srgbClr val="1E293B"/>
-                </a:solidFill>
-              </a:defRPr>
-            </a:pPr>
-            <a:r>
-              <a:t>✔ Infrastructure &amp; Cloud Cost (COGS):</a:t>
-            </a:r>
-          </a:p>
-          <a:p>
-            <a:pPr>
-              <a:spcAft>
-                <a:spcPts val="400"/>
-              </a:spcAft>
-              <a:defRPr sz="1200">
-                <a:solidFill>
-                  <a:srgbClr val="1E293B"/>
-                </a:solidFill>
-              </a:defRPr>
-            </a:pPr>
-            <a:r>
-              <a:t>✔   • Cloud compute &amp; storage cost: ~$4.00 per 1M receipts.</a:t>
-            </a:r>
-          </a:p>
-          <a:p>
-            <a:pPr>
-              <a:spcAft>
-                <a:spcPts val="400"/>
-              </a:spcAft>
-              <a:defRPr sz="1200">
-                <a:solidFill>
-                  <a:srgbClr val="1E293B"/>
-                </a:solidFill>
-              </a:defRPr>
-            </a:pPr>
-            <a:r>
-              <a:t>✔   • Verification Gross Margin: &gt; 98%.</a:t>
+              <a:t>✔   • Fully compliant with GDPR, CCPA, and DPDP by design.</a:t>
             </a:r>
           </a:p>
         </p:txBody>

</xml_diff>